<commit_message>
Extractions des cartes en anglais
</commit_message>
<xml_diff>
--- a/pictures/Deck-en/Deck-en.pptx
+++ b/pictures/Deck-en/Deck-en.pptx
@@ -203,7 +203,7 @@
           <a:p>
             <a:fld id="{263B0988-6DB9-4E3D-B7FD-EFF3BCABE954}" type="datetimeFigureOut">
               <a:rPr lang="fr-FR" smtClean="0"/>
-              <a:t>17/04/2026</a:t>
+              <a:t>18/04/2026</a:t>
             </a:fld>
             <a:endParaRPr lang="fr-FR"/>
           </a:p>
@@ -638,6 +638,90 @@
 </p:notes>
 </file>
 
+<file path=ppt/notesSlides/notesSlide3.xml><?xml version="1.0" encoding="utf-8"?>
+<p:notes xmlns:a="http://schemas.openxmlformats.org/drawingml/2006/main" xmlns:r="http://schemas.openxmlformats.org/officeDocument/2006/relationships" xmlns:p="http://schemas.openxmlformats.org/presentationml/2006/main">
+  <p:cSld>
+    <p:spTree>
+      <p:nvGrpSpPr>
+        <p:cNvPr id="1" name=""/>
+        <p:cNvGrpSpPr/>
+        <p:nvPr/>
+      </p:nvGrpSpPr>
+      <p:grpSpPr>
+        <a:xfrm>
+          <a:off x="0" y="0"/>
+          <a:ext cx="0" cy="0"/>
+          <a:chOff x="0" y="0"/>
+          <a:chExt cx="0" cy="0"/>
+        </a:xfrm>
+      </p:grpSpPr>
+      <p:sp>
+        <p:nvSpPr>
+          <p:cNvPr id="2" name="Espace réservé de l'image des diapositives 1"/>
+          <p:cNvSpPr>
+            <a:spLocks noGrp="1" noRot="1" noChangeAspect="1"/>
+          </p:cNvSpPr>
+          <p:nvPr>
+            <p:ph type="sldImg"/>
+          </p:nvPr>
+        </p:nvSpPr>
+        <p:spPr/>
+      </p:sp>
+      <p:sp>
+        <p:nvSpPr>
+          <p:cNvPr id="3" name="Espace réservé des notes 2"/>
+          <p:cNvSpPr>
+            <a:spLocks noGrp="1"/>
+          </p:cNvSpPr>
+          <p:nvPr>
+            <p:ph type="body" idx="1"/>
+          </p:nvPr>
+        </p:nvSpPr>
+        <p:spPr/>
+        <p:txBody>
+          <a:bodyPr/>
+          <a:lstStyle/>
+          <a:p>
+            <a:endParaRPr lang="fr-FR" dirty="0"/>
+          </a:p>
+        </p:txBody>
+      </p:sp>
+      <p:sp>
+        <p:nvSpPr>
+          <p:cNvPr id="4" name="Espace réservé du numéro de diapositive 3"/>
+          <p:cNvSpPr>
+            <a:spLocks noGrp="1"/>
+          </p:cNvSpPr>
+          <p:nvPr>
+            <p:ph type="sldNum" sz="quarter" idx="5"/>
+          </p:nvPr>
+        </p:nvSpPr>
+        <p:spPr/>
+        <p:txBody>
+          <a:bodyPr/>
+          <a:lstStyle/>
+          <a:p>
+            <a:fld id="{D3B0DD9D-2173-49B3-B084-704F33D21705}" type="slidenum">
+              <a:rPr lang="fr-FR" smtClean="0"/>
+              <a:t>6</a:t>
+            </a:fld>
+            <a:endParaRPr lang="fr-FR"/>
+          </a:p>
+        </p:txBody>
+      </p:sp>
+    </p:spTree>
+    <p:extLst>
+      <p:ext uri="{BB962C8B-B14F-4D97-AF65-F5344CB8AC3E}">
+        <p14:creationId xmlns:p14="http://schemas.microsoft.com/office/powerpoint/2010/main" val="3726237277"/>
+      </p:ext>
+    </p:extLst>
+  </p:cSld>
+  <p:clrMapOvr>
+    <a:masterClrMapping/>
+  </p:clrMapOvr>
+</p:notes>
+</file>
+
 <file path=ppt/slideLayouts/slideLayout1.xml><?xml version="1.0" encoding="utf-8"?>
 <p:sldLayout xmlns:a="http://schemas.openxmlformats.org/drawingml/2006/main" xmlns:r="http://schemas.openxmlformats.org/officeDocument/2006/relationships" xmlns:p="http://schemas.openxmlformats.org/presentationml/2006/main" type="title" preserve="1">
   <p:cSld name="Diapositive de titre">
@@ -785,7 +869,7 @@
           <a:p>
             <a:fld id="{588505E2-0C4C-443F-8F57-41958F504CA2}" type="datetimeFigureOut">
               <a:rPr lang="fr-FR" smtClean="0"/>
-              <a:t>17/04/2026</a:t>
+              <a:t>18/04/2026</a:t>
             </a:fld>
             <a:endParaRPr lang="fr-FR"/>
           </a:p>
@@ -983,7 +1067,7 @@
           <a:p>
             <a:fld id="{588505E2-0C4C-443F-8F57-41958F504CA2}" type="datetimeFigureOut">
               <a:rPr lang="fr-FR" smtClean="0"/>
-              <a:t>17/04/2026</a:t>
+              <a:t>18/04/2026</a:t>
             </a:fld>
             <a:endParaRPr lang="fr-FR"/>
           </a:p>
@@ -1191,7 +1275,7 @@
           <a:p>
             <a:fld id="{588505E2-0C4C-443F-8F57-41958F504CA2}" type="datetimeFigureOut">
               <a:rPr lang="fr-FR" smtClean="0"/>
-              <a:t>17/04/2026</a:t>
+              <a:t>18/04/2026</a:t>
             </a:fld>
             <a:endParaRPr lang="fr-FR"/>
           </a:p>
@@ -1389,7 +1473,7 @@
           <a:p>
             <a:fld id="{588505E2-0C4C-443F-8F57-41958F504CA2}" type="datetimeFigureOut">
               <a:rPr lang="fr-FR" smtClean="0"/>
-              <a:t>17/04/2026</a:t>
+              <a:t>18/04/2026</a:t>
             </a:fld>
             <a:endParaRPr lang="fr-FR"/>
           </a:p>
@@ -1664,7 +1748,7 @@
           <a:p>
             <a:fld id="{588505E2-0C4C-443F-8F57-41958F504CA2}" type="datetimeFigureOut">
               <a:rPr lang="fr-FR" smtClean="0"/>
-              <a:t>17/04/2026</a:t>
+              <a:t>18/04/2026</a:t>
             </a:fld>
             <a:endParaRPr lang="fr-FR"/>
           </a:p>
@@ -1929,7 +2013,7 @@
           <a:p>
             <a:fld id="{588505E2-0C4C-443F-8F57-41958F504CA2}" type="datetimeFigureOut">
               <a:rPr lang="fr-FR" smtClean="0"/>
-              <a:t>17/04/2026</a:t>
+              <a:t>18/04/2026</a:t>
             </a:fld>
             <a:endParaRPr lang="fr-FR"/>
           </a:p>
@@ -2341,7 +2425,7 @@
           <a:p>
             <a:fld id="{588505E2-0C4C-443F-8F57-41958F504CA2}" type="datetimeFigureOut">
               <a:rPr lang="fr-FR" smtClean="0"/>
-              <a:t>17/04/2026</a:t>
+              <a:t>18/04/2026</a:t>
             </a:fld>
             <a:endParaRPr lang="fr-FR"/>
           </a:p>
@@ -2482,7 +2566,7 @@
           <a:p>
             <a:fld id="{588505E2-0C4C-443F-8F57-41958F504CA2}" type="datetimeFigureOut">
               <a:rPr lang="fr-FR" smtClean="0"/>
-              <a:t>17/04/2026</a:t>
+              <a:t>18/04/2026</a:t>
             </a:fld>
             <a:endParaRPr lang="fr-FR"/>
           </a:p>
@@ -2595,7 +2679,7 @@
           <a:p>
             <a:fld id="{588505E2-0C4C-443F-8F57-41958F504CA2}" type="datetimeFigureOut">
               <a:rPr lang="fr-FR" smtClean="0"/>
-              <a:t>17/04/2026</a:t>
+              <a:t>18/04/2026</a:t>
             </a:fld>
             <a:endParaRPr lang="fr-FR"/>
           </a:p>
@@ -2906,7 +2990,7 @@
           <a:p>
             <a:fld id="{588505E2-0C4C-443F-8F57-41958F504CA2}" type="datetimeFigureOut">
               <a:rPr lang="fr-FR" smtClean="0"/>
-              <a:t>17/04/2026</a:t>
+              <a:t>18/04/2026</a:t>
             </a:fld>
             <a:endParaRPr lang="fr-FR"/>
           </a:p>
@@ -3194,7 +3278,7 @@
           <a:p>
             <a:fld id="{588505E2-0C4C-443F-8F57-41958F504CA2}" type="datetimeFigureOut">
               <a:rPr lang="fr-FR" smtClean="0"/>
-              <a:t>17/04/2026</a:t>
+              <a:t>18/04/2026</a:t>
             </a:fld>
             <a:endParaRPr lang="fr-FR"/>
           </a:p>
@@ -3435,7 +3519,7 @@
           <a:p>
             <a:fld id="{588505E2-0C4C-443F-8F57-41958F504CA2}" type="datetimeFigureOut">
               <a:rPr lang="fr-FR" smtClean="0"/>
-              <a:t>17/04/2026</a:t>
+              <a:t>18/04/2026</a:t>
             </a:fld>
             <a:endParaRPr lang="fr-FR"/>
           </a:p>
@@ -6239,10 +6323,10 @@
       </p:grpSp>
       <p:grpSp>
         <p:nvGrpSpPr>
-          <p:cNvPr id="13" name="Groupe 12">
+          <p:cNvPr id="19" name="Groupe 18">
             <a:extLst>
               <a:ext uri="{FF2B5EF4-FFF2-40B4-BE49-F238E27FC236}">
-                <a16:creationId xmlns:a16="http://schemas.microsoft.com/office/drawing/2014/main" id="{1CCB6775-8B51-D13F-E939-7B7902CC35E2}"/>
+                <a16:creationId xmlns:a16="http://schemas.microsoft.com/office/drawing/2014/main" id="{03089565-D921-A13C-5E53-2043696ED554}"/>
               </a:ext>
             </a:extLst>
           </p:cNvPr>
@@ -6253,7 +6337,7 @@
           <a:xfrm>
             <a:off x="6727546" y="846176"/>
             <a:ext cx="2124000" cy="3312000"/>
-            <a:chOff x="6981743" y="846176"/>
+            <a:chOff x="6727546" y="846176"/>
             <a:chExt cx="2124000" cy="3312000"/>
           </a:xfrm>
         </p:grpSpPr>
@@ -6271,7 +6355,7 @@
           </p:nvSpPr>
           <p:spPr>
             <a:xfrm>
-              <a:off x="6981743" y="846176"/>
+              <a:off x="6727546" y="846176"/>
               <a:ext cx="2124000" cy="3312000"/>
             </a:xfrm>
             <a:prstGeom prst="rect">
@@ -6324,7 +6408,7 @@
           </p:nvSpPr>
           <p:spPr>
             <a:xfrm>
-              <a:off x="7062485" y="3676934"/>
+              <a:off x="6808288" y="3676934"/>
               <a:ext cx="360000" cy="360000"/>
             </a:xfrm>
             <a:prstGeom prst="donut">
@@ -6386,7 +6470,7 @@
           </p:nvSpPr>
           <p:spPr>
             <a:xfrm rot="5400000">
-              <a:off x="8121280" y="3084940"/>
+              <a:off x="7867083" y="3084940"/>
               <a:ext cx="396000" cy="360000"/>
             </a:xfrm>
             <a:prstGeom prst="hexagon">
@@ -6453,7 +6537,7 @@
           </p:nvSpPr>
           <p:spPr>
             <a:xfrm rot="5400000">
-              <a:off x="7698639" y="3083335"/>
+              <a:off x="7444442" y="3083335"/>
               <a:ext cx="396000" cy="360000"/>
             </a:xfrm>
             <a:prstGeom prst="hexagon">
@@ -6509,7 +6593,7 @@
           </p:nvCxnSpPr>
           <p:spPr>
             <a:xfrm>
-              <a:off x="7895015" y="3256231"/>
+              <a:off x="7640818" y="3256231"/>
               <a:ext cx="481421" cy="12683"/>
             </a:xfrm>
             <a:prstGeom prst="straightConnector1">
@@ -6548,7 +6632,7 @@
           </p:nvSpPr>
           <p:spPr>
             <a:xfrm>
-              <a:off x="7167614" y="1389077"/>
+              <a:off x="6913417" y="1389077"/>
               <a:ext cx="1818049" cy="369332"/>
             </a:xfrm>
             <a:prstGeom prst="rect">
@@ -6617,7 +6701,7 @@
           </p:blipFill>
           <p:spPr>
             <a:xfrm>
-              <a:off x="7150124" y="1825443"/>
+              <a:off x="6895927" y="1825443"/>
               <a:ext cx="1133030" cy="981962"/>
             </a:xfrm>
             <a:prstGeom prst="rect">
@@ -6639,7 +6723,7 @@
           </p:nvSpPr>
           <p:spPr>
             <a:xfrm>
-              <a:off x="8362282" y="1841910"/>
+              <a:off x="8108085" y="1841910"/>
               <a:ext cx="622921" cy="738664"/>
             </a:xfrm>
             <a:prstGeom prst="rect">
@@ -6682,7 +6766,7 @@
           </p:nvSpPr>
           <p:spPr>
             <a:xfrm>
-              <a:off x="6981743" y="846176"/>
+              <a:off x="6727546" y="846176"/>
               <a:ext cx="432000" cy="432000"/>
             </a:xfrm>
             <a:prstGeom prst="rect">
@@ -6754,7 +6838,7 @@
           </p:nvSpPr>
           <p:spPr>
             <a:xfrm>
-              <a:off x="7413743" y="846176"/>
+              <a:off x="7159546" y="846176"/>
               <a:ext cx="1260000" cy="432000"/>
             </a:xfrm>
             <a:prstGeom prst="rect">
@@ -6825,7 +6909,7 @@
           </p:nvSpPr>
           <p:spPr>
             <a:xfrm>
-              <a:off x="8673743" y="846176"/>
+              <a:off x="8419546" y="846176"/>
               <a:ext cx="432000" cy="432000"/>
             </a:xfrm>
             <a:prstGeom prst="rect">
@@ -17072,7 +17156,7 @@
               <a:avLst/>
             </a:prstGeom>
             <a:blipFill dpi="0" rotWithShape="1">
-              <a:blip r:embed="rId2">
+              <a:blip r:embed="rId3">
                 <a:alphaModFix amt="90000"/>
               </a:blip>
               <a:srcRect/>
@@ -17125,11 +17209,11 @@
               <a:avLst/>
             </a:prstGeom>
             <a:blipFill dpi="0" rotWithShape="1">
-              <a:blip r:embed="rId3">
+              <a:blip r:embed="rId4">
                 <a:extLst>
                   <a:ext uri="{BEBA8EAE-BF5A-486C-A8C5-ECC9F3942E4B}">
                     <a14:imgProps xmlns:a14="http://schemas.microsoft.com/office/drawing/2010/main">
-                      <a14:imgLayer r:embed="rId4">
+                      <a14:imgLayer r:embed="rId5">
                         <a14:imgEffect>
                           <a14:artisticWatercolorSponge/>
                         </a14:imgEffect>
@@ -17290,11 +17374,11 @@
               <a:avLst/>
             </a:prstGeom>
             <a:blipFill>
-              <a:blip r:embed="rId5">
+              <a:blip r:embed="rId6">
                 <a:extLst>
                   <a:ext uri="{BEBA8EAE-BF5A-486C-A8C5-ECC9F3942E4B}">
                     <a14:imgProps xmlns:a14="http://schemas.microsoft.com/office/drawing/2010/main">
-                      <a14:imgLayer r:embed="rId6">
+                      <a14:imgLayer r:embed="rId7">
                         <a14:imgEffect>
                           <a14:brightnessContrast bright="-20000" contrast="-40000"/>
                         </a14:imgEffect>
@@ -17357,11 +17441,11 @@
               <a:avLst/>
             </a:prstGeom>
             <a:blipFill>
-              <a:blip r:embed="rId5">
+              <a:blip r:embed="rId6">
                 <a:extLst>
                   <a:ext uri="{BEBA8EAE-BF5A-486C-A8C5-ECC9F3942E4B}">
                     <a14:imgProps xmlns:a14="http://schemas.microsoft.com/office/drawing/2010/main">
-                      <a14:imgLayer r:embed="rId6">
+                      <a14:imgLayer r:embed="rId7">
                         <a14:imgEffect>
                           <a14:brightnessContrast bright="-20000" contrast="-40000"/>
                         </a14:imgEffect>
@@ -17424,7 +17508,7 @@
               <a:avLst/>
             </a:prstGeom>
             <a:blipFill>
-              <a:blip r:embed="rId7"/>
+              <a:blip r:embed="rId8"/>
               <a:tile tx="0" ty="0" sx="100000" sy="100000" flip="none" algn="tl"/>
             </a:blipFill>
             <a:ln w="12700">
@@ -17544,7 +17628,7 @@
             <a:blip>
               <a:extLst>
                 <a:ext uri="{96DAC541-7B7A-43D3-8B79-37D633B846F1}">
-                  <asvg:svgBlip xmlns:asvg="http://schemas.microsoft.com/office/drawing/2016/SVG/main" r:embed="rId8"/>
+                  <asvg:svgBlip xmlns:asvg="http://schemas.microsoft.com/office/drawing/2016/SVG/main" r:embed="rId9"/>
                 </a:ext>
               </a:extLst>
             </a:blip>
@@ -17605,7 +17689,7 @@
               <a:avLst/>
             </a:prstGeom>
             <a:blipFill dpi="0" rotWithShape="1">
-              <a:blip r:embed="rId2">
+              <a:blip r:embed="rId3">
                 <a:alphaModFix amt="90000"/>
               </a:blip>
               <a:srcRect/>
@@ -17658,11 +17742,11 @@
               <a:avLst/>
             </a:prstGeom>
             <a:blipFill dpi="0" rotWithShape="1">
-              <a:blip r:embed="rId3">
+              <a:blip r:embed="rId4">
                 <a:extLst>
                   <a:ext uri="{BEBA8EAE-BF5A-486C-A8C5-ECC9F3942E4B}">
                     <a14:imgProps xmlns:a14="http://schemas.microsoft.com/office/drawing/2010/main">
-                      <a14:imgLayer r:embed="rId4">
+                      <a14:imgLayer r:embed="rId5">
                         <a14:imgEffect>
                           <a14:artisticWatercolorSponge/>
                         </a14:imgEffect>
@@ -17782,11 +17866,11 @@
               <a:avLst/>
             </a:prstGeom>
             <a:blipFill>
-              <a:blip r:embed="rId5">
+              <a:blip r:embed="rId6">
                 <a:extLst>
                   <a:ext uri="{BEBA8EAE-BF5A-486C-A8C5-ECC9F3942E4B}">
                     <a14:imgProps xmlns:a14="http://schemas.microsoft.com/office/drawing/2010/main">
-                      <a14:imgLayer r:embed="rId6">
+                      <a14:imgLayer r:embed="rId7">
                         <a14:imgEffect>
                           <a14:brightnessContrast bright="-20000" contrast="-40000"/>
                         </a14:imgEffect>
@@ -17849,7 +17933,7 @@
               <a:avLst/>
             </a:prstGeom>
             <a:blipFill>
-              <a:blip r:embed="rId7"/>
+              <a:blip r:embed="rId8"/>
               <a:tile tx="0" ty="0" sx="100000" sy="100000" flip="none" algn="tl"/>
             </a:blipFill>
             <a:ln w="12700">
@@ -17904,7 +17988,7 @@
               <a:avLst/>
             </a:prstGeom>
             <a:blipFill>
-              <a:blip r:embed="rId7"/>
+              <a:blip r:embed="rId8"/>
               <a:tile tx="0" ty="0" sx="100000" sy="100000" flip="none" algn="tl"/>
             </a:blipFill>
             <a:ln w="12700">
@@ -17959,7 +18043,7 @@
               <a:avLst/>
             </a:prstGeom>
             <a:blipFill>
-              <a:blip r:embed="rId7"/>
+              <a:blip r:embed="rId8"/>
               <a:tile tx="0" ty="0" sx="100000" sy="100000" flip="none" algn="tl"/>
             </a:blipFill>
             <a:ln w="12700">
@@ -18014,11 +18098,11 @@
               <a:avLst/>
             </a:prstGeom>
             <a:blipFill>
-              <a:blip r:embed="rId5">
+              <a:blip r:embed="rId6">
                 <a:extLst>
                   <a:ext uri="{BEBA8EAE-BF5A-486C-A8C5-ECC9F3942E4B}">
                     <a14:imgProps xmlns:a14="http://schemas.microsoft.com/office/drawing/2010/main">
-                      <a14:imgLayer r:embed="rId6">
+                      <a14:imgLayer r:embed="rId7">
                         <a14:imgEffect>
                           <a14:brightnessContrast bright="-20000" contrast="-40000"/>
                         </a14:imgEffect>
@@ -18221,7 +18305,7 @@
             <a:blip>
               <a:extLst>
                 <a:ext uri="{96DAC541-7B7A-43D3-8B79-37D633B846F1}">
-                  <asvg:svgBlip xmlns:asvg="http://schemas.microsoft.com/office/drawing/2016/SVG/main" r:embed="rId8"/>
+                  <asvg:svgBlip xmlns:asvg="http://schemas.microsoft.com/office/drawing/2016/SVG/main" r:embed="rId9"/>
                 </a:ext>
               </a:extLst>
             </a:blip>
@@ -18282,7 +18366,7 @@
               <a:avLst/>
             </a:prstGeom>
             <a:blipFill dpi="0" rotWithShape="1">
-              <a:blip r:embed="rId2">
+              <a:blip r:embed="rId3">
                 <a:alphaModFix amt="90000"/>
               </a:blip>
               <a:srcRect/>
@@ -18335,11 +18419,11 @@
               <a:avLst/>
             </a:prstGeom>
             <a:blipFill dpi="0" rotWithShape="1">
-              <a:blip r:embed="rId3">
+              <a:blip r:embed="rId4">
                 <a:extLst>
                   <a:ext uri="{BEBA8EAE-BF5A-486C-A8C5-ECC9F3942E4B}">
                     <a14:imgProps xmlns:a14="http://schemas.microsoft.com/office/drawing/2010/main">
-                      <a14:imgLayer r:embed="rId4">
+                      <a14:imgLayer r:embed="rId5">
                         <a14:imgEffect>
                           <a14:artisticWatercolorSponge/>
                         </a14:imgEffect>
@@ -18459,11 +18543,11 @@
               <a:avLst/>
             </a:prstGeom>
             <a:blipFill>
-              <a:blip r:embed="rId5">
+              <a:blip r:embed="rId6">
                 <a:extLst>
                   <a:ext uri="{BEBA8EAE-BF5A-486C-A8C5-ECC9F3942E4B}">
                     <a14:imgProps xmlns:a14="http://schemas.microsoft.com/office/drawing/2010/main">
-                      <a14:imgLayer r:embed="rId6">
+                      <a14:imgLayer r:embed="rId7">
                         <a14:imgEffect>
                           <a14:brightnessContrast bright="-20000" contrast="-40000"/>
                         </a14:imgEffect>
@@ -18526,7 +18610,7 @@
               <a:avLst/>
             </a:prstGeom>
             <a:blipFill>
-              <a:blip r:embed="rId7"/>
+              <a:blip r:embed="rId8"/>
               <a:tile tx="0" ty="0" sx="100000" sy="100000" flip="none" algn="tl"/>
             </a:blipFill>
             <a:ln w="12700">
@@ -18581,7 +18665,7 @@
               <a:avLst/>
             </a:prstGeom>
             <a:blipFill>
-              <a:blip r:embed="rId7"/>
+              <a:blip r:embed="rId8"/>
               <a:tile tx="0" ty="0" sx="100000" sy="100000" flip="none" algn="tl"/>
             </a:blipFill>
             <a:ln w="12700">
@@ -18636,7 +18720,7 @@
               <a:avLst/>
             </a:prstGeom>
             <a:blipFill>
-              <a:blip r:embed="rId7"/>
+              <a:blip r:embed="rId8"/>
               <a:tile tx="0" ty="0" sx="100000" sy="100000" flip="none" algn="tl"/>
             </a:blipFill>
             <a:ln w="12700">
@@ -18691,11 +18775,11 @@
               <a:avLst/>
             </a:prstGeom>
             <a:blipFill>
-              <a:blip r:embed="rId5">
+              <a:blip r:embed="rId6">
                 <a:extLst>
                   <a:ext uri="{BEBA8EAE-BF5A-486C-A8C5-ECC9F3942E4B}">
                     <a14:imgProps xmlns:a14="http://schemas.microsoft.com/office/drawing/2010/main">
-                      <a14:imgLayer r:embed="rId6">
+                      <a14:imgLayer r:embed="rId7">
                         <a14:imgEffect>
                           <a14:brightnessContrast bright="-20000" contrast="-40000"/>
                         </a14:imgEffect>
@@ -18918,7 +19002,7 @@
             <a:blip>
               <a:extLst>
                 <a:ext uri="{96DAC541-7B7A-43D3-8B79-37D633B846F1}">
-                  <asvg:svgBlip xmlns:asvg="http://schemas.microsoft.com/office/drawing/2016/SVG/main" r:embed="rId8"/>
+                  <asvg:svgBlip xmlns:asvg="http://schemas.microsoft.com/office/drawing/2016/SVG/main" r:embed="rId9"/>
                 </a:ext>
               </a:extLst>
             </a:blip>

</xml_diff>